<commit_message>
Pass language guardrail: rephrase 'no detecta corrupción' → 'no emite juicios'
The non-accusatory guardrail tokenizer matches 'detecta corrupcion' as a
substring even under negation. Replacing across CONTEST_SUBMISSION, the
Claude Design brief/prompt and the deck v3 generator. Rebuild .pptx + .pdf.

validate-final now exits 0; 71/71 tests pass.
</commit_message>
<xml_diff>
--- a/slides/contratia_abierta_deck_v3.pptx
+++ b/slides/contratia_abierta_deck_v3.pptx
@@ -3333,7 +3333,7 @@
               </a:defRPr>
             </a:pPr>
             <a:r>
-              <a:t>No detectamos corrupción.  Ordenamos qué revisar primero, con evidencia trazable.</a:t>
+              <a:t>No emitimos juicios de corrupción.  Ordenamos qué revisar primero, con evidencia trazable.</a:t>
             </a:r>
           </a:p>
         </p:txBody>
@@ -6403,7 +6403,7 @@
               </a:defRPr>
             </a:pPr>
             <a:r>
-              <a:t>No detectamos corrupción. Ordenamos qué revisar primero, con evidencia trazable.</a:t>
+              <a:t>No emitimos juicios de corrupción. Ordenamos qué revisar primero, con evidencia trazable.</a:t>
             </a:r>
           </a:p>
         </p:txBody>

</xml_diff>